<commit_message>
e2e add more tools
</commit_message>
<xml_diff>
--- a/e2e_test_deck.pptx
+++ b/e2e_test_deck.pptx
@@ -3639,11 +3639,11 @@
         </p:nvSpPr>
         <p:spPr/>
         <p:txBody>
-          <a:bodyPr/>
-          <a:lstStyle/>
-          <a:p>
-            <a:r>
-              <a:t>Production-grade PowerPoint manipulation for AI agents</a:t>
+          <a:bodyPr wrap="square"/>
+          <a:lstStyle/>
+          <a:p>
+            <a:r>
+              <a:t>Updated subtitle</a:t>
             </a:r>
           </a:p>
         </p:txBody>
@@ -3691,7 +3691,7 @@
         </p:nvSpPr>
         <p:spPr>
           <a:xfrm>
-            <a:off x="11216359" y="6309360"/>
+            <a:off x="7772400" y="6309360"/>
             <a:ext cx="609584" cy="342900"/>
           </a:xfrm>
           <a:prstGeom prst="rect">
@@ -3782,8 +3782,8 @@
         </p:nvSpPr>
         <p:spPr>
           <a:xfrm>
-            <a:off x="1219169" y="1714500"/>
-            <a:ext cx="9753356" cy="4114800"/>
+            <a:off x="914400" y="1828800"/>
+            <a:ext cx="7315200" cy="4114800"/>
           </a:xfrm>
           <a:prstGeom prst="rect">
             <a:avLst/>
@@ -3904,7 +3904,7 @@
         </p:nvSpPr>
         <p:spPr>
           <a:xfrm>
-            <a:off x="11216359" y="6309360"/>
+            <a:off x="7772400" y="6309360"/>
             <a:ext cx="609584" cy="342900"/>
           </a:xfrm>
           <a:prstGeom prst="rect">
@@ -3995,8 +3995,8 @@
         </p:nvSpPr>
         <p:spPr>
           <a:xfrm>
-            <a:off x="1219169" y="1714500"/>
-            <a:ext cx="9753356" cy="4114800"/>
+            <a:off x="914400" y="1828800"/>
+            <a:ext cx="7315200" cy="4114800"/>
           </a:xfrm>
           <a:prstGeom prst="rect">
             <a:avLst/>
@@ -4085,7 +4085,7 @@
         </p:nvSpPr>
         <p:spPr>
           <a:xfrm>
-            <a:off x="11216359" y="6309360"/>
+            <a:off x="7772400" y="6309360"/>
             <a:ext cx="609584" cy="342900"/>
           </a:xfrm>
           <a:prstGeom prst="rect">
@@ -4176,8 +4176,8 @@
         </p:nvSpPr>
         <p:spPr>
           <a:xfrm>
-            <a:off x="1219169" y="1714500"/>
-            <a:ext cx="9753356" cy="4114800"/>
+            <a:off x="914400" y="1828800"/>
+            <a:ext cx="7315200" cy="4114800"/>
           </a:xfrm>
           <a:prstGeom prst="rect">
             <a:avLst/>
@@ -4265,7 +4265,7 @@
         </p:nvSpPr>
         <p:spPr>
           <a:xfrm>
-            <a:off x="11216359" y="6309360"/>
+            <a:off x="7772400" y="6309360"/>
             <a:ext cx="609584" cy="342900"/>
           </a:xfrm>
           <a:prstGeom prst="rect">
@@ -4348,17 +4348,87 @@
           <a:p/>
         </p:txBody>
       </p:sp>
+      <p:sp>
+        <p:nvSpPr>
+          <p:cNvPr id="5" name="TextBox 4"/>
+          <p:cNvSpPr txBox="1"/>
+          <p:nvPr/>
+        </p:nvSpPr>
+        <p:spPr>
+          <a:xfrm>
+            <a:off x="609584" y="6309360"/>
+            <a:ext cx="7315017" cy="342900"/>
+          </a:xfrm>
+          <a:prstGeom prst="rect">
+            <a:avLst/>
+          </a:prstGeom>
+          <a:noFill/>
+        </p:spPr>
+        <p:txBody>
+          <a:bodyPr wrap="square">
+            <a:spAutoFit/>
+          </a:bodyPr>
+          <a:lstStyle/>
+          <a:p>
+            <a:pPr algn="l">
+              <a:defRPr sz="1000" b="0" i="0">
+                <a:solidFill>
+                  <a:srgbClr val="595959"/>
+                </a:solidFill>
+              </a:defRPr>
+            </a:pPr>
+            <a:r>
+              <a:t>PowerPoint Agent Tools</a:t>
+            </a:r>
+          </a:p>
+        </p:txBody>
+      </p:sp>
+      <p:sp>
+        <p:nvSpPr>
+          <p:cNvPr id="6" name="TextBox 5"/>
+          <p:cNvSpPr txBox="1"/>
+          <p:nvPr/>
+        </p:nvSpPr>
+        <p:spPr>
+          <a:xfrm>
+            <a:off x="7772400" y="6309360"/>
+            <a:ext cx="609584" cy="342900"/>
+          </a:xfrm>
+          <a:prstGeom prst="rect">
+            <a:avLst/>
+          </a:prstGeom>
+          <a:noFill/>
+        </p:spPr>
+        <p:txBody>
+          <a:bodyPr wrap="square">
+            <a:spAutoFit/>
+          </a:bodyPr>
+          <a:lstStyle/>
+          <a:p>
+            <a:pPr algn="l">
+              <a:defRPr sz="1000" b="0" i="0">
+                <a:solidFill>
+                  <a:srgbClr val="595959"/>
+                </a:solidFill>
+              </a:defRPr>
+            </a:pPr>
+            <a:r>
+              <a:t>5</a:t>
+            </a:r>
+          </a:p>
+        </p:txBody>
+      </p:sp>
       <p:graphicFrame>
         <p:nvGraphicFramePr>
-          <p:cNvPr id="4" name="Table 3"/>
+          <p:cNvPr id="7" name="Table 6"/>
           <p:cNvGraphicFramePr>
             <a:graphicFrameLocks noGrp="1"/>
           </p:cNvGraphicFramePr>
           <p:nvPr/>
         </p:nvGraphicFramePr>
         <p:xfrm>
-          <a:off x="1219169" y="1920240"/>
-          <a:ext cx="9753356" cy="3771900"/>
+          <a:off x="914400" y="1828800"/>
+          <a:ext cx="7315200" cy="3657600"/>
         </p:xfrm>
         <a:graphic>
           <a:graphicData uri="http://schemas.openxmlformats.org/drawingml/2006/table">
@@ -4367,11 +4437,11 @@
                 <a:tableStyleId>{5C22544A-7EE6-4342-B048-85BDC9FD1C3A}</a:tableStyleId>
               </a:tblPr>
               <a:tblGrid>
-                <a:gridCol w="3251118"/>
-                <a:gridCol w="3251118"/>
-                <a:gridCol w="3251120"/>
+                <a:gridCol w="2438400"/>
+                <a:gridCol w="2438400"/>
+                <a:gridCol w="2438400"/>
               </a:tblGrid>
-              <a:tr h="754380">
+              <a:tr h="731520">
                 <a:tc>
                   <a:txBody>
                     <a:bodyPr/>
@@ -4409,7 +4479,7 @@
                   <a:tcPr/>
                 </a:tc>
               </a:tr>
-              <a:tr h="754380">
+              <a:tr h="731520">
                 <a:tc>
                   <a:txBody>
                     <a:bodyPr/>
@@ -4447,7 +4517,7 @@
                   <a:tcPr/>
                 </a:tc>
               </a:tr>
-              <a:tr h="754380">
+              <a:tr h="731520">
                 <a:tc>
                   <a:txBody>
                     <a:bodyPr/>
@@ -4485,7 +4555,7 @@
                   <a:tcPr/>
                 </a:tc>
               </a:tr>
-              <a:tr h="754380">
+              <a:tr h="731520">
                 <a:tc>
                   <a:txBody>
                     <a:bodyPr/>
@@ -4523,7 +4593,7 @@
                   <a:tcPr/>
                 </a:tc>
               </a:tr>
-              <a:tr h="754380">
+              <a:tr h="731520">
                 <a:tc>
                   <a:txBody>
                     <a:bodyPr/>
@@ -4565,76 +4635,6 @@
           </a:graphicData>
         </a:graphic>
       </p:graphicFrame>
-      <p:sp>
-        <p:nvSpPr>
-          <p:cNvPr id="5" name="TextBox 4"/>
-          <p:cNvSpPr txBox="1"/>
-          <p:nvPr/>
-        </p:nvSpPr>
-        <p:spPr>
-          <a:xfrm>
-            <a:off x="609584" y="6309360"/>
-            <a:ext cx="7315017" cy="342900"/>
-          </a:xfrm>
-          <a:prstGeom prst="rect">
-            <a:avLst/>
-          </a:prstGeom>
-          <a:noFill/>
-        </p:spPr>
-        <p:txBody>
-          <a:bodyPr wrap="square">
-            <a:spAutoFit/>
-          </a:bodyPr>
-          <a:lstStyle/>
-          <a:p>
-            <a:pPr algn="l">
-              <a:defRPr sz="1000" b="0" i="0">
-                <a:solidFill>
-                  <a:srgbClr val="595959"/>
-                </a:solidFill>
-              </a:defRPr>
-            </a:pPr>
-            <a:r>
-              <a:t>PowerPoint Agent Tools</a:t>
-            </a:r>
-          </a:p>
-        </p:txBody>
-      </p:sp>
-      <p:sp>
-        <p:nvSpPr>
-          <p:cNvPr id="6" name="TextBox 5"/>
-          <p:cNvSpPr txBox="1"/>
-          <p:nvPr/>
-        </p:nvSpPr>
-        <p:spPr>
-          <a:xfrm>
-            <a:off x="11216359" y="6309360"/>
-            <a:ext cx="609584" cy="342900"/>
-          </a:xfrm>
-          <a:prstGeom prst="rect">
-            <a:avLst/>
-          </a:prstGeom>
-          <a:noFill/>
-        </p:spPr>
-        <p:txBody>
-          <a:bodyPr wrap="square">
-            <a:spAutoFit/>
-          </a:bodyPr>
-          <a:lstStyle/>
-          <a:p>
-            <a:pPr algn="l">
-              <a:defRPr sz="1000" b="0" i="0">
-                <a:solidFill>
-                  <a:srgbClr val="595959"/>
-                </a:solidFill>
-              </a:defRPr>
-            </a:pPr>
-            <a:r>
-              <a:t>5</a:t>
-            </a:r>
-          </a:p>
-        </p:txBody>
-      </p:sp>
     </p:spTree>
   </p:cSld>
   <p:clrMapOvr>
@@ -4647,60 +4647,16 @@
 <p:sld xmlns:a="http://schemas.openxmlformats.org/drawingml/2006/main" xmlns:p="http://schemas.openxmlformats.org/presentationml/2006/main" xmlns:r="http://schemas.openxmlformats.org/officeDocument/2006/relationships">
   <p:cSld>
     <p:spTree>
-      <p:nvGrpSpPr>
-        <p:cNvPr id="1" name=""/>
-        <p:cNvGrpSpPr/>
-        <p:nvPr/>
-      </p:nvGrpSpPr>
-      <p:grpSpPr/>
-      <p:sp>
-        <p:nvSpPr>
-          <p:cNvPr id="2" name="Title 1"/>
-          <p:cNvSpPr>
-            <a:spLocks noGrp="1"/>
-          </p:cNvSpPr>
-          <p:nvPr>
-            <p:ph type="title"/>
-          </p:nvPr>
-        </p:nvSpPr>
-        <p:spPr/>
-        <p:txBody>
-          <a:bodyPr/>
-          <a:lstStyle/>
-          <a:p>
-            <a:r>
-              <a:t>Architecture</a:t>
-            </a:r>
-          </a:p>
-        </p:txBody>
-      </p:sp>
-      <p:sp>
-        <p:nvSpPr>
-          <p:cNvPr id="3" name="Content Placeholder 2"/>
-          <p:cNvSpPr>
-            <a:spLocks noGrp="1"/>
-          </p:cNvSpPr>
-          <p:nvPr>
-            <p:ph idx="1"/>
-          </p:nvPr>
-        </p:nvSpPr>
-        <p:spPr/>
-        <p:txBody>
-          <a:bodyPr/>
-          <a:lstStyle/>
-          <a:p/>
-        </p:txBody>
-      </p:sp>
-      <p:sp>
-        <p:nvSpPr>
-          <p:cNvPr id="4" name="Rectangle 3"/>
+      <p:sp>
+        <p:nvSpPr>
+          <p:cNvPr id="7" name="Rectangle 6"/>
           <p:cNvSpPr/>
           <p:nvPr/>
         </p:nvSpPr>
         <p:spPr>
           <a:xfrm>
             <a:off x="0" y="0"/>
-            <a:ext cx="12191695" cy="6858000"/>
+            <a:ext cx="9144000" cy="6858000"/>
           </a:xfrm>
           <a:prstGeom prst="rect">
             <a:avLst/>
@@ -4736,84 +4692,48 @@
           </a:p>
         </p:txBody>
       </p:sp>
-      <p:sp>
-        <p:nvSpPr>
-          <p:cNvPr id="5" name="TextBox 4"/>
-          <p:cNvSpPr txBox="1"/>
-          <p:nvPr/>
-        </p:nvSpPr>
-        <p:spPr>
-          <a:xfrm>
-            <a:off x="1219169" y="1714500"/>
-            <a:ext cx="9753356" cy="4114800"/>
-          </a:xfrm>
-          <a:prstGeom prst="rect">
-            <a:avLst/>
-          </a:prstGeom>
-          <a:noFill/>
-        </p:spPr>
-        <p:txBody>
-          <a:bodyPr wrap="square">
-            <a:spAutoFit/>
-          </a:bodyPr>
-          <a:lstStyle/>
-          <a:p>
-            <a:pPr algn="l">
-              <a:defRPr sz="1800" b="0" i="0">
-                <a:latin typeface="Calibri"/>
-              </a:defRPr>
-            </a:pPr>
-            <a:r>
-              <a:t>Hub-and-Spoke Architecture</a:t>
-            </a:r>
-          </a:p>
+      <p:nvGrpSpPr>
+        <p:cNvPr id="1" name=""/>
+        <p:cNvGrpSpPr/>
+        <p:nvPr/>
+      </p:nvGrpSpPr>
+      <p:grpSpPr/>
+      <p:sp>
+        <p:nvSpPr>
+          <p:cNvPr id="2" name="Title 1"/>
+          <p:cNvSpPr>
+            <a:spLocks noGrp="1"/>
+          </p:cNvSpPr>
+          <p:nvPr>
+            <p:ph type="title"/>
+          </p:nvPr>
+        </p:nvSpPr>
+        <p:spPr/>
+        <p:txBody>
+          <a:bodyPr/>
+          <a:lstStyle/>
+          <a:p>
+            <a:r>
+              <a:t>Architecture</a:t>
+            </a:r>
+          </a:p>
+        </p:txBody>
+      </p:sp>
+      <p:sp>
+        <p:nvSpPr>
+          <p:cNvPr id="3" name="Content Placeholder 2"/>
+          <p:cNvSpPr>
+            <a:spLocks noGrp="1"/>
+          </p:cNvSpPr>
+          <p:nvPr>
+            <p:ph idx="1"/>
+          </p:nvPr>
+        </p:nvSpPr>
+        <p:spPr/>
+        <p:txBody>
+          <a:bodyPr/>
+          <a:lstStyle/>
           <a:p/>
-          <a:p>
-            <a:r>
-              <a:t>Core: powerpoint_agent_core.py (4,437 lines)</a:t>
-            </a:r>
-          </a:p>
-          <a:p>
-            <a:r>
-              <a:t>  - Atomic file locking</a:t>
-            </a:r>
-          </a:p>
-          <a:p>
-            <a:r>
-              <a:t>  - Geometry-aware versioning</a:t>
-            </a:r>
-          </a:p>
-          <a:p>
-            <a:r>
-              <a:t>  - OOXML manipulation (opacity, z-order)</a:t>
-            </a:r>
-          </a:p>
-          <a:p>
-            <a:r>
-              <a:t>  - 14 specialized exceptions</a:t>
-            </a:r>
-          </a:p>
-          <a:p/>
-          <a:p>
-            <a:r>
-              <a:t>Spokes: 42 stateless CLI tools</a:t>
-            </a:r>
-          </a:p>
-          <a:p>
-            <a:r>
-              <a:t>  - JSON-first I/O</a:t>
-            </a:r>
-          </a:p>
-          <a:p>
-            <a:r>
-              <a:t>  - Output hygiene (stderr suppressed)</a:t>
-            </a:r>
-          </a:p>
-          <a:p>
-            <a:r>
-              <a:t>  - Exit codes 0-5</a:t>
-            </a:r>
-          </a:p>
         </p:txBody>
       </p:sp>
       <p:sp>
@@ -4853,14 +4773,14 @@
       </p:sp>
       <p:sp>
         <p:nvSpPr>
-          <p:cNvPr id="7" name="TextBox 6"/>
+          <p:cNvPr id="8" name="TextBox 7"/>
           <p:cNvSpPr txBox="1"/>
           <p:nvPr/>
         </p:nvSpPr>
         <p:spPr>
           <a:xfrm>
-            <a:off x="11216359" y="6309360"/>
-            <a:ext cx="609584" cy="342900"/>
+            <a:off x="914400" y="1828800"/>
+            <a:ext cx="7315200" cy="3657600"/>
           </a:xfrm>
           <a:prstGeom prst="rect">
             <a:avLst/>
@@ -4874,60 +4794,93 @@
           <a:lstStyle/>
           <a:p>
             <a:pPr algn="l">
-              <a:defRPr sz="1000" b="0" i="0">
-                <a:solidFill>
-                  <a:srgbClr val="595959"/>
-                </a:solidFill>
+              <a:defRPr sz="1800" b="0" i="0">
+                <a:latin typeface="Calibri"/>
               </a:defRPr>
             </a:pPr>
             <a:r>
-              <a:t>6</a:t>
-            </a:r>
-          </a:p>
-        </p:txBody>
-      </p:sp>
-      <p:sp>
-        <p:nvSpPr>
-          <p:cNvPr id="8" name="Rectangle 7"/>
-          <p:cNvSpPr/>
+              <a:t>Hub-and-Spoke Architecture</a:t>
+            </a:r>
+          </a:p>
+          <a:p/>
+          <a:p>
+            <a:r>
+              <a:t>Core: powerpoint_agent_core.py (4,437 lines)</a:t>
+            </a:r>
+          </a:p>
+          <a:p>
+            <a:r>
+              <a:t>  - Atomic file locking</a:t>
+            </a:r>
+          </a:p>
+          <a:p>
+            <a:r>
+              <a:t>  - Geometry-aware versioning</a:t>
+            </a:r>
+          </a:p>
+          <a:p>
+            <a:r>
+              <a:t>  - OOXML manipulation (opacity, z-order)</a:t>
+            </a:r>
+          </a:p>
+          <a:p>
+            <a:r>
+              <a:t>  - 14 specialized exceptions</a:t>
+            </a:r>
+          </a:p>
+          <a:p/>
+          <a:p>
+            <a:r>
+              <a:t>Spokes: 42 stateless CLI tools</a:t>
+            </a:r>
+          </a:p>
+          <a:p>
+            <a:r>
+              <a:t>  - JSON-first I/O</a:t>
+            </a:r>
+          </a:p>
+          <a:p>
+            <a:r>
+              <a:t>  - Output hygiene (stderr suppressed)</a:t>
+            </a:r>
+          </a:p>
+          <a:p>
+            <a:r>
+              <a:t>  - Exit codes 0-5</a:t>
+            </a:r>
+          </a:p>
+        </p:txBody>
+      </p:sp>
+      <p:sp>
+        <p:nvSpPr>
+          <p:cNvPr id="9" name="TextBox 8"/>
+          <p:cNvSpPr txBox="1"/>
           <p:nvPr/>
         </p:nvSpPr>
         <p:spPr>
           <a:xfrm>
-            <a:off x="6095847" y="3429000"/>
-            <a:ext cx="1219169" cy="685800"/>
+            <a:off x="7772400" y="6309360"/>
+            <a:ext cx="914400" cy="365760"/>
           </a:xfrm>
           <a:prstGeom prst="rect">
             <a:avLst/>
           </a:prstGeom>
-          <a:solidFill>
-            <a:srgbClr val="FF0000">
-              <a:alpha val="50000"/>
-            </a:srgbClr>
-          </a:solidFill>
-          <a:ln>
-            <a:noFill/>
-          </a:ln>
+          <a:noFill/>
         </p:spPr>
-        <p:style>
-          <a:lnRef idx="1">
-            <a:schemeClr val="accent1"/>
-          </a:lnRef>
-          <a:fillRef idx="3">
-            <a:schemeClr val="accent1"/>
-          </a:fillRef>
-          <a:effectRef idx="2">
-            <a:schemeClr val="accent1"/>
-          </a:effectRef>
-          <a:fontRef idx="minor">
-            <a:schemeClr val="lt1"/>
-          </a:fontRef>
-        </p:style>
-        <p:txBody>
-          <a:bodyPr rtlCol="0" anchor="ctr"/>
-          <a:lstStyle/>
-          <a:p>
-            <a:pPr algn="ctr"/>
+        <p:txBody>
+          <a:bodyPr wrap="square">
+            <a:spAutoFit/>
+          </a:bodyPr>
+          <a:lstStyle/>
+          <a:p>
+            <a:pPr algn="l">
+              <a:defRPr sz="1800" b="0" i="0">
+                <a:latin typeface="Calibri"/>
+              </a:defRPr>
+            </a:pPr>
+            <a:r>
+              <a:t>6</a:t>
+            </a:r>
           </a:p>
         </p:txBody>
       </p:sp>
@@ -4995,8 +4948,8 @@
         </p:nvSpPr>
         <p:spPr>
           <a:xfrm>
-            <a:off x="1219169" y="1714500"/>
-            <a:ext cx="9753356" cy="2743200"/>
+            <a:off x="914400" y="1828800"/>
+            <a:ext cx="7315200" cy="2743200"/>
           </a:xfrm>
           <a:prstGeom prst="rect">
             <a:avLst/>
@@ -5085,7 +5038,7 @@
         </p:nvSpPr>
         <p:spPr>
           <a:xfrm>
-            <a:off x="11216359" y="6309360"/>
+            <a:off x="7772400" y="6309360"/>
             <a:ext cx="609584" cy="342900"/>
           </a:xfrm>
           <a:prstGeom prst="rect">

</xml_diff>